<commit_message>
Remove dates from pptx and remove few_seconds idea
</commit_message>
<xml_diff>
--- a/plan/initalpresentation.pptx
+++ b/plan/initalpresentation.pptx
@@ -268,10 +268,107 @@
       </p15:sldGuideLst>
     </p:ext>
     <p:ext uri="GoogleSlidesCustomDataVersion2">
-      <go:slidesCustomData xmlns:go="http://customooxmlschemas.google.com/" xmlns:ahyp="http://schemas.microsoft.com/office/drawing/2018/hyperlinkcolor" xmlns:p15="http://schemas.microsoft.com/office/powerpoint/2012/main" xmlns:p14="http://schemas.microsoft.com/office/powerpoint/2010/main" xmlns:com="http://schemas.openxmlformats.org/drawingml/2006/compatibility" xmlns:pvml="urn:schemas-microsoft-com:office:powerpoint" xmlns:v="urn:schemas-microsoft-com:vml" xmlns:o="urn:schemas-microsoft-com:office:office" xmlns:dgm="http://schemas.openxmlformats.org/drawingml/2006/diagram" xmlns:c="http://schemas.openxmlformats.org/drawingml/2006/chart" xmlns:mv="urn:schemas-microsoft-com:mac:vml" xmlns:mc="http://schemas.openxmlformats.org/markup-compatibility/2006" xmlns="" r:id="rId18" roundtripDataSignature="AMtx7mjpqNaG+RC56AwOCMSj2yNYu2zqUQ=="/>
+      <go:slidesCustomData xmlns="" xmlns:mc="http://schemas.openxmlformats.org/markup-compatibility/2006" xmlns:mv="urn:schemas-microsoft-com:mac:vml" xmlns:c="http://schemas.openxmlformats.org/drawingml/2006/chart" xmlns:dgm="http://schemas.openxmlformats.org/drawingml/2006/diagram" xmlns:o="urn:schemas-microsoft-com:office:office" xmlns:v="urn:schemas-microsoft-com:vml" xmlns:pvml="urn:schemas-microsoft-com:office:powerpoint" xmlns:com="http://schemas.openxmlformats.org/drawingml/2006/compatibility" xmlns:p14="http://schemas.microsoft.com/office/powerpoint/2010/main" xmlns:p15="http://schemas.microsoft.com/office/powerpoint/2012/main" xmlns:ahyp="http://schemas.microsoft.com/office/drawing/2018/hyperlinkcolor" xmlns:go="http://customooxmlschemas.google.com/" r:id="rId18" roundtripDataSignature="AMtx7mjpqNaG+RC56AwOCMSj2yNYu2zqUQ=="/>
     </p:ext>
   </p:extLst>
 </p:presentation>
+</file>
+
+<file path=ppt/changesInfos/changesInfo1.xml><?xml version="1.0" encoding="utf-8"?>
+<pc:chgInfo xmlns:a="http://schemas.openxmlformats.org/drawingml/2006/main" xmlns:r="http://schemas.openxmlformats.org/officeDocument/2006/relationships" xmlns:ac="http://schemas.microsoft.com/office/drawing/2013/main/command" xmlns:pc="http://schemas.microsoft.com/office/powerpoint/2013/main/command">
+  <pc:docChgLst>
+    <pc:chgData name="Fabian Stiewe" userId="0ad49742f936a350" providerId="LiveId" clId="{3EEDD559-442E-EA47-AB3A-14339A053DA6}"/>
+    <pc:docChg chg="custSel modSld">
+      <pc:chgData name="Fabian Stiewe" userId="0ad49742f936a350" providerId="LiveId" clId="{3EEDD559-442E-EA47-AB3A-14339A053DA6}" dt="2025-11-14T06:32:04.478" v="8" actId="20577"/>
+      <pc:docMkLst>
+        <pc:docMk/>
+      </pc:docMkLst>
+      <pc:sldChg chg="delSp mod">
+        <pc:chgData name="Fabian Stiewe" userId="0ad49742f936a350" providerId="LiveId" clId="{3EEDD559-442E-EA47-AB3A-14339A053DA6}" dt="2025-11-14T06:31:25.113" v="3" actId="478"/>
+        <pc:sldMkLst>
+          <pc:docMk/>
+          <pc:sldMk cId="0" sldId="266"/>
+        </pc:sldMkLst>
+        <pc:spChg chg="del">
+          <ac:chgData name="Fabian Stiewe" userId="0ad49742f936a350" providerId="LiveId" clId="{3EEDD559-442E-EA47-AB3A-14339A053DA6}" dt="2025-11-14T06:31:25.113" v="3" actId="478"/>
+          <ac:spMkLst>
+            <pc:docMk/>
+            <pc:sldMk cId="0" sldId="266"/>
+            <ac:spMk id="157" creationId="{00000000-0000-0000-0000-000000000000}"/>
+          </ac:spMkLst>
+        </pc:spChg>
+      </pc:sldChg>
+      <pc:sldChg chg="delSp mod">
+        <pc:chgData name="Fabian Stiewe" userId="0ad49742f936a350" providerId="LiveId" clId="{3EEDD559-442E-EA47-AB3A-14339A053DA6}" dt="2025-11-14T06:31:16.076" v="0" actId="478"/>
+        <pc:sldMkLst>
+          <pc:docMk/>
+          <pc:sldMk cId="3718797627" sldId="282"/>
+        </pc:sldMkLst>
+        <pc:spChg chg="del">
+          <ac:chgData name="Fabian Stiewe" userId="0ad49742f936a350" providerId="LiveId" clId="{3EEDD559-442E-EA47-AB3A-14339A053DA6}" dt="2025-11-14T06:31:16.076" v="0" actId="478"/>
+          <ac:spMkLst>
+            <pc:docMk/>
+            <pc:sldMk cId="3718797627" sldId="282"/>
+            <ac:spMk id="6" creationId="{AA41D2BE-A128-E34D-6064-81C5FF2B91FD}"/>
+          </ac:spMkLst>
+        </pc:spChg>
+      </pc:sldChg>
+      <pc:sldChg chg="delSp modSp mod">
+        <pc:chgData name="Fabian Stiewe" userId="0ad49742f936a350" providerId="LiveId" clId="{3EEDD559-442E-EA47-AB3A-14339A053DA6}" dt="2025-11-14T06:31:21.975" v="2" actId="478"/>
+        <pc:sldMkLst>
+          <pc:docMk/>
+          <pc:sldMk cId="1279758690" sldId="283"/>
+        </pc:sldMkLst>
+        <pc:spChg chg="del mod">
+          <ac:chgData name="Fabian Stiewe" userId="0ad49742f936a350" providerId="LiveId" clId="{3EEDD559-442E-EA47-AB3A-14339A053DA6}" dt="2025-11-14T06:31:21.975" v="2" actId="478"/>
+          <ac:spMkLst>
+            <pc:docMk/>
+            <pc:sldMk cId="1279758690" sldId="283"/>
+            <ac:spMk id="6" creationId="{DC49F7DD-0C67-7C20-EBDD-E181DA1B3DCD}"/>
+          </ac:spMkLst>
+        </pc:spChg>
+      </pc:sldChg>
+      <pc:sldChg chg="delSp modSp mod">
+        <pc:chgData name="Fabian Stiewe" userId="0ad49742f936a350" providerId="LiveId" clId="{3EEDD559-442E-EA47-AB3A-14339A053DA6}" dt="2025-11-14T06:32:04.478" v="8" actId="20577"/>
+        <pc:sldMkLst>
+          <pc:docMk/>
+          <pc:sldMk cId="1342985379" sldId="284"/>
+        </pc:sldMkLst>
+        <pc:spChg chg="mod">
+          <ac:chgData name="Fabian Stiewe" userId="0ad49742f936a350" providerId="LiveId" clId="{3EEDD559-442E-EA47-AB3A-14339A053DA6}" dt="2025-11-14T06:32:04.478" v="8" actId="20577"/>
+          <ac:spMkLst>
+            <pc:docMk/>
+            <pc:sldMk cId="1342985379" sldId="284"/>
+            <ac:spMk id="2" creationId="{D00DD17F-E258-640D-A821-E9CD05EB9310}"/>
+          </ac:spMkLst>
+        </pc:spChg>
+        <pc:spChg chg="del">
+          <ac:chgData name="Fabian Stiewe" userId="0ad49742f936a350" providerId="LiveId" clId="{3EEDD559-442E-EA47-AB3A-14339A053DA6}" dt="2025-11-14T06:31:34.944" v="5" actId="478"/>
+          <ac:spMkLst>
+            <pc:docMk/>
+            <pc:sldMk cId="1342985379" sldId="284"/>
+            <ac:spMk id="5" creationId="{AF772B8A-3944-D1A5-AB17-099B4114F016}"/>
+          </ac:spMkLst>
+        </pc:spChg>
+      </pc:sldChg>
+      <pc:sldChg chg="delSp mod">
+        <pc:chgData name="Fabian Stiewe" userId="0ad49742f936a350" providerId="LiveId" clId="{3EEDD559-442E-EA47-AB3A-14339A053DA6}" dt="2025-11-14T06:31:30.858" v="4" actId="478"/>
+        <pc:sldMkLst>
+          <pc:docMk/>
+          <pc:sldMk cId="615348299" sldId="286"/>
+        </pc:sldMkLst>
+        <pc:spChg chg="del">
+          <ac:chgData name="Fabian Stiewe" userId="0ad49742f936a350" providerId="LiveId" clId="{3EEDD559-442E-EA47-AB3A-14339A053DA6}" dt="2025-11-14T06:31:30.858" v="4" actId="478"/>
+          <ac:spMkLst>
+            <pc:docMk/>
+            <pc:sldMk cId="615348299" sldId="286"/>
+            <ac:spMk id="6" creationId="{7DE94CF1-22E7-9916-9393-1E5ABB642947}"/>
+          </ac:spMkLst>
+        </pc:spChg>
+      </pc:sldChg>
+    </pc:docChg>
+  </pc:docChgLst>
+</pc:chgInfo>
 </file>
 
 <file path=ppt/handoutMasters/handoutMaster1.xml><?xml version="1.0" encoding="utf-8"?>
@@ -368,7 +465,7 @@
           <a:p>
             <a:fld id="{D59AAE17-292B-40FA-8691-962AFFA4433D}" type="datetimeFigureOut">
               <a:rPr lang="de-DE" smtClean="0"/>
-              <a:t>11.11.2025</a:t>
+              <a:t>14.11.25</a:t>
             </a:fld>
             <a:endParaRPr lang="de-DE"/>
           </a:p>
@@ -446,7 +543,7 @@
           <a:p>
             <a:fld id="{7DBAE938-9A43-48D6-B636-665FA3098917}" type="slidenum">
               <a:rPr lang="de-DE" smtClean="0"/>
-              <a:t>‹Nr.›</a:t>
+              <a:t>‹#›</a:t>
             </a:fld>
             <a:endParaRPr lang="de-DE"/>
           </a:p>
@@ -1408,7 +1505,7 @@
                 <a:cs typeface="Calibri"/>
                 <a:sym typeface="Calibri"/>
               </a:rPr>
-              <a:t>‹Nr.›</a:t>
+              <a:t>‹#›</a:t>
             </a:fld>
             <a:endParaRPr sz="1200" b="0" i="0" u="none" strike="noStrike" cap="none">
               <a:solidFill>
@@ -6207,26 +6304,6 @@
             <a:pPr lvl="1"/>
             <a:r>
               <a:rPr lang="de-DE" sz="2000" dirty="0"/>
-              <a:t>New </a:t>
-            </a:r>
-            <a:r>
-              <a:rPr lang="de-DE" sz="2000" dirty="0" err="1"/>
-              <a:t>label</a:t>
-            </a:r>
-            <a:r>
-              <a:rPr lang="de-DE" sz="2000" dirty="0"/>
-              <a:t> : </a:t>
-            </a:r>
-            <a:r>
-              <a:rPr lang="de-DE" sz="2000" dirty="0" err="1"/>
-              <a:t>few_seconds</a:t>
-            </a:r>
-            <a:endParaRPr lang="de-DE" sz="2000" dirty="0"/>
-          </a:p>
-          <a:p>
-            <a:pPr lvl="1"/>
-            <a:r>
-              <a:rPr lang="de-DE" sz="2000" dirty="0"/>
               <a:t>Multidimensional Labels</a:t>
             </a:r>
           </a:p>
@@ -6329,34 +6406,6 @@
             <a:r>
               <a:rPr lang="de-DE"/>
               <a:t>(Add slide number)</a:t>
-            </a:r>
-          </a:p>
-        </p:txBody>
-      </p:sp>
-      <p:sp>
-        <p:nvSpPr>
-          <p:cNvPr id="5" name="Fußzeilenplatzhalter 4">
-            <a:extLst>
-              <a:ext uri="{FF2B5EF4-FFF2-40B4-BE49-F238E27FC236}">
-                <a16:creationId xmlns:a16="http://schemas.microsoft.com/office/drawing/2014/main" id="{AF772B8A-3944-D1A5-AB17-099B4114F016}"/>
-              </a:ext>
-            </a:extLst>
-          </p:cNvPr>
-          <p:cNvSpPr>
-            <a:spLocks noGrp="1"/>
-          </p:cNvSpPr>
-          <p:nvPr>
-            <p:ph type="ftr" idx="11"/>
-          </p:nvPr>
-        </p:nvSpPr>
-        <p:spPr/>
-        <p:txBody>
-          <a:bodyPr/>
-          <a:lstStyle/>
-          <a:p>
-            <a:r>
-              <a:rPr lang="de-DE"/>
-              <a:t>Seminar mit Bachelorarbeit, 28.10.2025</a:t>
             </a:r>
           </a:p>
         </p:txBody>
@@ -6664,34 +6713,6 @@
           </a:p>
         </p:txBody>
       </p:sp>
-      <p:sp>
-        <p:nvSpPr>
-          <p:cNvPr id="6" name="Fußzeilenplatzhalter 5">
-            <a:extLst>
-              <a:ext uri="{FF2B5EF4-FFF2-40B4-BE49-F238E27FC236}">
-                <a16:creationId xmlns:a16="http://schemas.microsoft.com/office/drawing/2014/main" id="{7DE94CF1-22E7-9916-9393-1E5ABB642947}"/>
-              </a:ext>
-            </a:extLst>
-          </p:cNvPr>
-          <p:cNvSpPr>
-            <a:spLocks noGrp="1"/>
-          </p:cNvSpPr>
-          <p:nvPr>
-            <p:ph type="ftr" idx="11"/>
-          </p:nvPr>
-        </p:nvSpPr>
-        <p:spPr/>
-        <p:txBody>
-          <a:bodyPr/>
-          <a:lstStyle/>
-          <a:p>
-            <a:r>
-              <a:rPr lang="de-DE"/>
-              <a:t>Seminar mit Bachelorarbeit, 28.10.2025</a:t>
-            </a:r>
-          </a:p>
-        </p:txBody>
-      </p:sp>
     </p:spTree>
     <p:extLst>
       <p:ext uri="{BB962C8B-B14F-4D97-AF65-F5344CB8AC3E}">
@@ -7152,34 +7173,6 @@
             <a:r>
               <a:rPr lang="de-DE"/>
               <a:t>(Add slide number)</a:t>
-            </a:r>
-          </a:p>
-        </p:txBody>
-      </p:sp>
-      <p:sp>
-        <p:nvSpPr>
-          <p:cNvPr id="6" name="Fußzeilenplatzhalter 5">
-            <a:extLst>
-              <a:ext uri="{FF2B5EF4-FFF2-40B4-BE49-F238E27FC236}">
-                <a16:creationId xmlns:a16="http://schemas.microsoft.com/office/drawing/2014/main" id="{AA41D2BE-A128-E34D-6064-81C5FF2B91FD}"/>
-              </a:ext>
-            </a:extLst>
-          </p:cNvPr>
-          <p:cNvSpPr>
-            <a:spLocks noGrp="1"/>
-          </p:cNvSpPr>
-          <p:nvPr>
-            <p:ph type="ftr" idx="11"/>
-          </p:nvPr>
-        </p:nvSpPr>
-        <p:spPr/>
-        <p:txBody>
-          <a:bodyPr/>
-          <a:lstStyle/>
-          <a:p>
-            <a:r>
-              <a:rPr lang="de-DE" dirty="0"/>
-              <a:t>28.10.2025</a:t>
             </a:r>
           </a:p>
         </p:txBody>
@@ -7524,34 +7517,6 @@
             <a:r>
               <a:rPr lang="de-DE"/>
               <a:t>(Add slide number)</a:t>
-            </a:r>
-          </a:p>
-        </p:txBody>
-      </p:sp>
-      <p:sp>
-        <p:nvSpPr>
-          <p:cNvPr id="6" name="Fußzeilenplatzhalter 5">
-            <a:extLst>
-              <a:ext uri="{FF2B5EF4-FFF2-40B4-BE49-F238E27FC236}">
-                <a16:creationId xmlns:a16="http://schemas.microsoft.com/office/drawing/2014/main" id="{DC49F7DD-0C67-7C20-EBDD-E181DA1B3DCD}"/>
-              </a:ext>
-            </a:extLst>
-          </p:cNvPr>
-          <p:cNvSpPr>
-            <a:spLocks noGrp="1"/>
-          </p:cNvSpPr>
-          <p:nvPr>
-            <p:ph type="ftr" idx="11"/>
-          </p:nvPr>
-        </p:nvSpPr>
-        <p:spPr/>
-        <p:txBody>
-          <a:bodyPr/>
-          <a:lstStyle/>
-          <a:p>
-            <a:r>
-              <a:rPr lang="de-DE"/>
-              <a:t>Seminar mit Bachelorarbeit, 28.10.2025</a:t>
             </a:r>
           </a:p>
         </p:txBody>
@@ -7642,51 +7607,6 @@
               <a:t>Questions?</a:t>
             </a:r>
             <a:endParaRPr lang="en-US" dirty="0"/>
-          </a:p>
-        </p:txBody>
-      </p:sp>
-      <p:sp>
-        <p:nvSpPr>
-          <p:cNvPr id="157" name="Google Shape;157;p9"/>
-          <p:cNvSpPr txBox="1">
-            <a:spLocks noGrp="1"/>
-          </p:cNvSpPr>
-          <p:nvPr>
-            <p:ph type="ftr" idx="11"/>
-          </p:nvPr>
-        </p:nvSpPr>
-        <p:spPr>
-          <a:xfrm>
-            <a:off x="3631389" y="6520260"/>
-            <a:ext cx="5002741" cy="365125"/>
-          </a:xfrm>
-          <a:prstGeom prst="rect">
-            <a:avLst/>
-          </a:prstGeom>
-          <a:noFill/>
-          <a:ln>
-            <a:noFill/>
-          </a:ln>
-        </p:spPr>
-        <p:txBody>
-          <a:bodyPr spcFirstLastPara="1" wrap="square" lIns="91425" tIns="45700" rIns="91425" bIns="45700" anchor="ctr" anchorCtr="0">
-            <a:noAutofit/>
-          </a:bodyPr>
-          <a:lstStyle/>
-          <a:p>
-            <a:pPr marL="0" lvl="0" indent="0" algn="ctr" rtl="0">
-              <a:spcBef>
-                <a:spcPts val="0"/>
-              </a:spcBef>
-              <a:spcAft>
-                <a:spcPts val="0"/>
-              </a:spcAft>
-              <a:buNone/>
-            </a:pPr>
-            <a:r>
-              <a:rPr lang="en-US" dirty="0"/>
-              <a:t> 28.10.2025</a:t>
-            </a:r>
           </a:p>
         </p:txBody>
       </p:sp>

</xml_diff>